<commit_message>
feat: round 24 - DECK rebuilt (numbers now read from the repo: 4 rounds, 68 criteria), contact-sheet preview, 11/12 pages fully clean
Co-authored-by: arena-agent <297053741+arena-agent@users.noreply.github.com>
</commit_message>
<xml_diff>
--- a/deliverable/DECK_01a0aa00_v2.8.1.pptx
+++ b/deliverable/DECK_01a0aa00_v2.8.1.pptx
@@ -1234,7 +1234,7 @@
                   <a:ea typeface="+mn-ea"/>
                   <a:cs typeface="+mn-cs"/>
                 </a:rPr>
-                <a:t>3 / 3 轮</a:t>
+                <a:t>4 / 4 轮</a:t>
               </a:r>
             </a:p>
           </p:txBody>
@@ -1274,7 +1274,7 @@
                   <a:ea typeface="+mn-ea"/>
                   <a:cs typeface="+mn-cs"/>
                 </a:rPr>
-                <a:t>真机判定 passed</a:t>
+                <a:t>真机逐轮 passed</a:t>
               </a:r>
             </a:p>
           </p:txBody>
@@ -1486,7 +1486,7 @@
                   <a:ea typeface="+mn-ea"/>
                   <a:cs typeface="+mn-cs"/>
                 </a:rPr>
-                <a:t>60 条成功标准全过</a:t>
+                <a:t>68 条成功标准全过</a:t>
               </a:r>
             </a:p>
           </p:txBody>
@@ -3532,7 +3532,7 @@
                   <a:ea typeface="+mj-ea"/>
                   <a:cs typeface="+mj-cs"/>
                 </a:rPr>
-                <a:t>results/status/handshake.json · round 22 · accepted · local_state=passed</a:t>
+                <a:t>results/status/handshake.json · round 23 · accepted · local_state=passed</a:t>
               </a:r>
             </a:p>
           </p:txBody>
@@ -11845,9 +11845,9 @@
         <p:grpSpPr>
           <a:xfrm>
             <a:off x="649986" y="613410"/>
-            <a:ext cx="6599484" cy="1194435"/>
+            <a:ext cx="6107481" cy="1194435"/>
             <a:chOff x="649986" y="613410"/>
-            <a:chExt cx="6599484" cy="1194435"/>
+            <a:chExt cx="6107481" cy="1194435"/>
           </a:xfrm>
         </p:grpSpPr>
         <p:sp>
@@ -11899,7 +11899,7 @@
           <p:spPr>
             <a:xfrm>
               <a:off x="649986" y="958215"/>
-              <a:ext cx="6599484" cy="645414"/>
+              <a:ext cx="6107481" cy="645414"/>
             </a:xfrm>
             <a:prstGeom prst="rect">
               <a:avLst/>
@@ -11925,7 +11925,7 @@
                   <a:ea typeface="+mn-ea"/>
                   <a:cs typeface="+mn-cs"/>
                 </a:rPr>
-                <a:t>真机数据（三轮，全部 passed）</a:t>
+                <a:t>真机数据（4 轮全部 passed）</a:t>
               </a:r>
             </a:p>
           </p:txBody>
@@ -11939,7 +11939,7 @@
           <p:spPr>
             <a:xfrm>
               <a:off x="678180" y="1514475"/>
-              <a:ext cx="2842260" cy="293370"/>
+              <a:ext cx="5043297" cy="293370"/>
             </a:xfrm>
             <a:prstGeom prst="rect">
               <a:avLst/>
@@ -11965,7 +11965,7 @@
                   <a:ea typeface="+mn-ea"/>
                   <a:cs typeface="+mn-cs"/>
                 </a:rPr>
-                <a:t>耗时取自值守日志，不是估计值</a:t>
+                <a:t>耗时取自 results/status/check_r*.txt，不是估计值</a:t>
               </a:r>
             </a:p>
           </p:txBody>
@@ -12176,7 +12176,7 @@
           <p:spPr>
             <a:xfrm>
               <a:off x="903732" y="2459355"/>
-              <a:ext cx="689219" cy="410718"/>
+              <a:ext cx="184596" cy="410718"/>
             </a:xfrm>
             <a:prstGeom prst="rect">
               <a:avLst/>
@@ -12202,7 +12202,7 @@
                   <a:ea typeface="+mn-ea"/>
                   <a:cs typeface="+mn-cs"/>
                 </a:rPr>
-                <a:t>3 / 3</a:t>
+                <a:t>0</a:t>
               </a:r>
             </a:p>
           </p:txBody>
@@ -12216,7 +12216,7 @@
           <p:spPr>
             <a:xfrm>
               <a:off x="908685" y="2869406"/>
-              <a:ext cx="704992" cy="220028"/>
+              <a:ext cx="916076" cy="220028"/>
             </a:xfrm>
             <a:prstGeom prst="rect">
               <a:avLst/>
@@ -12242,7 +12242,7 @@
                   <a:ea typeface="+mn-ea"/>
                   <a:cs typeface="+mn-cs"/>
                 </a:rPr>
-                <a:t>轮 passed</a:t>
+                <a:t>失败 / 0 跳过</a:t>
               </a:r>
             </a:p>
           </p:txBody>
@@ -12323,7 +12323,7 @@
                   <a:ea typeface="+mn-ea"/>
                   <a:cs typeface="+mn-cs"/>
                 </a:rPr>
-                <a:t>60</a:t>
+                <a:t>68</a:t>
               </a:r>
             </a:p>
           </p:txBody>
@@ -12337,7 +12337,7 @@
           <p:spPr>
             <a:xfrm>
               <a:off x="3651885" y="2869406"/>
-              <a:ext cx="765302" cy="220028"/>
+              <a:ext cx="1066851" cy="220028"/>
             </a:xfrm>
             <a:prstGeom prst="rect">
               <a:avLst/>
@@ -12363,7 +12363,7 @@
                   <a:ea typeface="+mn-ea"/>
                   <a:cs typeface="+mn-cs"/>
                 </a:rPr>
-                <a:t>条成功标准</a:t>
+                <a:t>条成功标准全过</a:t>
               </a:r>
             </a:p>
           </p:txBody>
@@ -12418,25 +12418,25 @@
           <p:spPr>
             <a:xfrm>
               <a:off x="6390132" y="2459355"/>
-              <a:ext cx="184596" cy="410718"/>
-            </a:xfrm>
-            <a:prstGeom prst="rect">
-              <a:avLst/>
-            </a:prstGeom>
-            <a:noFill/>
-            <a:ln>
-              <a:noFill/>
-            </a:ln>
-          </p:spPr>
-          <p:txBody>
-            <a:bodyPr wrap="none" lIns="0" tIns="0" rIns="0" bIns="0" anchor="t" anchorCtr="0">
-              <a:spAutoFit/>
-            </a:bodyPr>
-            <a:lstStyle/>
-            <a:p>
-              <a:pPr algn="l"/>
-              <a:r>
-                <a:rPr lang="zh-CN" sz="2100" b="1" dirty="0">
+              <a:ext cx="1000898" cy="410718"/>
+            </a:xfrm>
+            <a:prstGeom prst="rect">
+              <a:avLst/>
+            </a:prstGeom>
+            <a:noFill/>
+            <a:ln>
+              <a:noFill/>
+            </a:ln>
+          </p:spPr>
+          <p:txBody>
+            <a:bodyPr wrap="none" lIns="0" tIns="0" rIns="0" bIns="0" anchor="t" anchorCtr="0">
+              <a:spAutoFit/>
+            </a:bodyPr>
+            <a:lstStyle/>
+            <a:p>
+              <a:pPr algn="l"/>
+              <a:r>
+                <a:rPr lang="en-US" sz="2100" b="1" dirty="0">
                   <a:solidFill>
                     <a:srgbClr val="7DD3FC"/>
                   </a:solidFill>
@@ -12444,7 +12444,7 @@
                   <a:ea typeface="+mn-ea"/>
                   <a:cs typeface="+mn-cs"/>
                 </a:rPr>
-                <a:t>0</a:t>
+                <a:t>27–43s</a:t>
               </a:r>
             </a:p>
           </p:txBody>
@@ -12458,7 +12458,7 @@
           <p:spPr>
             <a:xfrm>
               <a:off x="6395085" y="2869406"/>
-              <a:ext cx="916076" cy="220028"/>
+              <a:ext cx="1217625" cy="220028"/>
             </a:xfrm>
             <a:prstGeom prst="rect">
               <a:avLst/>
@@ -12484,7 +12484,7 @@
                   <a:ea typeface="+mn-ea"/>
                   <a:cs typeface="+mn-cs"/>
                 </a:rPr>
-                <a:t>失败 / 0 跳过</a:t>
+                <a:t>单轮耗时（真机）</a:t>
               </a:r>
             </a:p>
           </p:txBody>
@@ -12619,9 +12619,9 @@
         </p:nvGrpSpPr>
         <p:grpSpPr>
           <a:xfrm>
-            <a:off x="2381250" y="3870008"/>
+            <a:off x="1714500" y="3870008"/>
             <a:ext cx="914400" cy="1868043"/>
-            <a:chOff x="2381250" y="3870008"/>
+            <a:chOff x="1714500" y="3870008"/>
             <a:chExt cx="914400" cy="1868043"/>
           </a:xfrm>
         </p:grpSpPr>
@@ -12633,7 +12633,7 @@
           </p:nvSpPr>
           <p:spPr>
             <a:xfrm>
-              <a:off x="2381250" y="4181475"/>
+              <a:off x="1714500" y="4181475"/>
               <a:ext cx="914400" cy="1152525"/>
             </a:xfrm>
             <a:prstGeom prst="roundRect">
@@ -12642,7 +12642,7 @@
               </a:avLst>
             </a:prstGeom>
             <a:solidFill>
-              <a:srgbClr val="22D3EE">
+              <a:srgbClr val="A3E635">
                 <a:alpha val="90000"/>
               </a:srgbClr>
             </a:solidFill>
@@ -12659,7 +12659,7 @@
           </p:nvSpPr>
           <p:spPr>
             <a:xfrm>
-              <a:off x="2646817" y="3870008"/>
+              <a:off x="1980067" y="3870008"/>
               <a:ext cx="383267" cy="322707"/>
             </a:xfrm>
             <a:prstGeom prst="rect">
@@ -12699,7 +12699,7 @@
           </p:nvSpPr>
           <p:spPr>
             <a:xfrm>
-              <a:off x="2454488" y="5474018"/>
+              <a:off x="1787738" y="5474018"/>
               <a:ext cx="767925" cy="264033"/>
             </a:xfrm>
             <a:prstGeom prst="rect">
@@ -12740,9 +12740,9 @@
         </p:nvGrpSpPr>
         <p:grpSpPr>
           <a:xfrm>
-            <a:off x="4762500" y="3565208"/>
+            <a:off x="3524250" y="3565208"/>
             <a:ext cx="914400" cy="2172843"/>
-            <a:chOff x="4762500" y="3565208"/>
+            <a:chOff x="3524250" y="3565208"/>
             <a:chExt cx="914400" cy="2172843"/>
           </a:xfrm>
         </p:grpSpPr>
@@ -12754,7 +12754,7 @@
           </p:nvSpPr>
           <p:spPr>
             <a:xfrm>
-              <a:off x="4762500" y="3876675"/>
+              <a:off x="3524250" y="3876675"/>
               <a:ext cx="914400" cy="1457325"/>
             </a:xfrm>
             <a:prstGeom prst="roundRect">
@@ -12763,7 +12763,7 @@
               </a:avLst>
             </a:prstGeom>
             <a:solidFill>
-              <a:srgbClr val="60A5FA">
+              <a:srgbClr val="A3E635">
                 <a:alpha val="90000"/>
               </a:srgbClr>
             </a:solidFill>
@@ -12780,7 +12780,7 @@
           </p:nvSpPr>
           <p:spPr>
             <a:xfrm>
-              <a:off x="5028067" y="3565208"/>
+              <a:off x="3789817" y="3565208"/>
               <a:ext cx="383267" cy="322707"/>
             </a:xfrm>
             <a:prstGeom prst="rect">
@@ -12820,7 +12820,7 @@
           </p:nvSpPr>
           <p:spPr>
             <a:xfrm>
-              <a:off x="4835738" y="5474018"/>
+              <a:off x="3597488" y="5474018"/>
               <a:ext cx="767925" cy="264033"/>
             </a:xfrm>
             <a:prstGeom prst="rect">
@@ -12861,10 +12861,10 @@
         </p:nvGrpSpPr>
         <p:grpSpPr>
           <a:xfrm>
-            <a:off x="7143750" y="3736658"/>
-            <a:ext cx="914400" cy="2001393"/>
-            <a:chOff x="7143750" y="3736658"/>
-            <a:chExt cx="914400" cy="2001393"/>
+            <a:off x="5334000" y="3184208"/>
+            <a:ext cx="914400" cy="2553843"/>
+            <a:chOff x="5334000" y="3184208"/>
+            <a:chExt cx="914400" cy="2553843"/>
           </a:xfrm>
         </p:grpSpPr>
         <p:sp>
@@ -12875,8 +12875,8 @@
           </p:nvSpPr>
           <p:spPr>
             <a:xfrm>
-              <a:off x="7143750" y="4048125"/>
-              <a:ext cx="914400" cy="1285875"/>
+              <a:off x="5334000" y="3495675"/>
+              <a:ext cx="914400" cy="1838325"/>
             </a:xfrm>
             <a:prstGeom prst="roundRect">
               <a:avLst>
@@ -12901,7 +12901,7 @@
           </p:nvSpPr>
           <p:spPr>
             <a:xfrm>
-              <a:off x="7409317" y="3736658"/>
+              <a:off x="5599567" y="3184208"/>
               <a:ext cx="383267" cy="322707"/>
             </a:xfrm>
             <a:prstGeom prst="rect">
@@ -12928,7 +12928,7 @@
                   <a:ea typeface="+mj-ea"/>
                   <a:cs typeface="+mj-cs"/>
                 </a:rPr>
-                <a:t>30s</a:t>
+                <a:t>43s</a:t>
               </a:r>
             </a:p>
           </p:txBody>
@@ -12941,7 +12941,7 @@
           </p:nvSpPr>
           <p:spPr>
             <a:xfrm>
-              <a:off x="7216988" y="5474018"/>
+              <a:off x="5407238" y="5474018"/>
               <a:ext cx="767925" cy="264033"/>
             </a:xfrm>
             <a:prstGeom prst="rect">
@@ -12974,16 +12974,137 @@
           </p:txBody>
         </p:sp>
       </p:grpSp>
+      <p:grpSp>
+        <p:nvGrpSpPr>
+          <p:cNvPr id="41" name="bar-4"/>
+          <p:cNvGrpSpPr/>
+          <p:nvPr/>
+        </p:nvGrpSpPr>
+        <p:grpSpPr>
+          <a:xfrm>
+            <a:off x="7143750" y="3565208"/>
+            <a:ext cx="914400" cy="2172843"/>
+            <a:chOff x="7143750" y="3565208"/>
+            <a:chExt cx="914400" cy="2172843"/>
+          </a:xfrm>
+        </p:grpSpPr>
+        <p:sp>
+          <p:nvSpPr>
+            <p:cNvPr id="38" name="Rectangle 38"/>
+            <p:cNvSpPr/>
+            <p:nvPr/>
+          </p:nvSpPr>
+          <p:spPr>
+            <a:xfrm>
+              <a:off x="7143750" y="3876675"/>
+              <a:ext cx="914400" cy="1457325"/>
+            </a:xfrm>
+            <a:prstGeom prst="roundRect">
+              <a:avLst>
+                <a:gd name="adj" fmla="val 6250"/>
+              </a:avLst>
+            </a:prstGeom>
+            <a:solidFill>
+              <a:srgbClr val="A3E635">
+                <a:alpha val="90000"/>
+              </a:srgbClr>
+            </a:solidFill>
+            <a:ln>
+              <a:noFill/>
+            </a:ln>
+          </p:spPr>
+        </p:sp>
+        <p:sp>
+          <p:nvSpPr>
+            <p:cNvPr id="39" name="TextBox 39"/>
+            <p:cNvSpPr txBox="1"/>
+            <p:nvPr/>
+          </p:nvSpPr>
+          <p:spPr>
+            <a:xfrm>
+              <a:off x="7409317" y="3565208"/>
+              <a:ext cx="383267" cy="322707"/>
+            </a:xfrm>
+            <a:prstGeom prst="rect">
+              <a:avLst/>
+            </a:prstGeom>
+            <a:noFill/>
+            <a:ln>
+              <a:noFill/>
+            </a:ln>
+          </p:spPr>
+          <p:txBody>
+            <a:bodyPr wrap="none" lIns="0" tIns="0" rIns="0" bIns="0" anchor="t" anchorCtr="0">
+              <a:spAutoFit/>
+            </a:bodyPr>
+            <a:lstStyle/>
+            <a:p>
+              <a:pPr algn="ctr"/>
+              <a:r>
+                <a:rPr lang="en-US" sz="1650" b="1" dirty="0">
+                  <a:solidFill>
+                    <a:srgbClr val="F1F5F9"/>
+                  </a:solidFill>
+                  <a:latin typeface="+mj-lt"/>
+                  <a:ea typeface="+mj-ea"/>
+                  <a:cs typeface="+mj-cs"/>
+                </a:rPr>
+                <a:t>34s</a:t>
+              </a:r>
+            </a:p>
+          </p:txBody>
+        </p:sp>
+        <p:sp>
+          <p:nvSpPr>
+            <p:cNvPr id="40" name="TextBox 40"/>
+            <p:cNvSpPr txBox="1"/>
+            <p:nvPr/>
+          </p:nvSpPr>
+          <p:spPr>
+            <a:xfrm>
+              <a:off x="7216988" y="5474018"/>
+              <a:ext cx="767925" cy="264033"/>
+            </a:xfrm>
+            <a:prstGeom prst="rect">
+              <a:avLst/>
+            </a:prstGeom>
+            <a:noFill/>
+            <a:ln>
+              <a:noFill/>
+            </a:ln>
+          </p:spPr>
+          <p:txBody>
+            <a:bodyPr wrap="none" lIns="0" tIns="0" rIns="0" bIns="0" anchor="t" anchorCtr="0">
+              <a:spAutoFit/>
+            </a:bodyPr>
+            <a:lstStyle/>
+            <a:p>
+              <a:pPr algn="ctr"/>
+              <a:r>
+                <a:rPr lang="en-US" sz="1350" dirty="0">
+                  <a:solidFill>
+                    <a:srgbClr val="94A3B8"/>
+                  </a:solidFill>
+                  <a:latin typeface="+mn-lt"/>
+                  <a:ea typeface="+mn-ea"/>
+                  <a:cs typeface="+mn-cs"/>
+                </a:rPr>
+                <a:t>round 23</a:t>
+              </a:r>
+            </a:p>
+          </p:txBody>
+        </p:sp>
+      </p:grpSp>
       <p:sp>
         <p:nvSpPr>
-          <p:cNvPr id="38" name="Line 38"/>
+          <p:cNvPr id="42" name="Line 42"/>
           <p:cNvSpPr/>
           <p:nvPr/>
         </p:nvSpPr>
         <p:spPr>
           <a:xfrm>
-            <a:off x="1714500" y="5334000"/>
-            <a:ext cx="9144000" cy="9525"/>
+            <a:off x="1428750" y="5334000"/>
+            <a:ext cx="7143750" cy="9525"/>
           </a:xfrm>
           <a:custGeom>
             <a:avLst/>
@@ -12992,12 +13113,12 @@
             <a:cxnLst/>
             <a:rect l="l" t="t" r="r" b="b"/>
             <a:pathLst>
-              <a:path w="9144000" h="9525">
+              <a:path w="7143750" h="9525">
                 <a:moveTo>
                   <a:pt x="0" y="0"/>
                 </a:moveTo>
                 <a:lnTo>
-                  <a:pt x="9144000" y="0"/>
+                  <a:pt x="7143750" y="0"/>
                 </a:lnTo>
               </a:path>
             </a:pathLst>
@@ -13012,21 +13133,21 @@
       </p:sp>
       <p:grpSp>
         <p:nvGrpSpPr>
-          <p:cNvPr id="41" name="numbers-host"/>
+          <p:cNvPr id="46" name="numbers-host"/>
           <p:cNvGrpSpPr/>
           <p:nvPr/>
         </p:nvGrpSpPr>
         <p:grpSpPr>
           <a:xfrm>
-            <a:off x="8628401" y="3629025"/>
-            <a:ext cx="2885419" cy="546259"/>
-            <a:chOff x="8628401" y="3629025"/>
-            <a:chExt cx="2885419" cy="546259"/>
+            <a:off x="9187543" y="3629025"/>
+            <a:ext cx="2326277" cy="774859"/>
+            <a:chOff x="9187543" y="3629025"/>
+            <a:chExt cx="2326277" cy="774859"/>
           </a:xfrm>
         </p:grpSpPr>
         <p:sp>
           <p:nvSpPr>
-            <p:cNvPr id="39" name="TextBox 39"/>
+            <p:cNvPr id="43" name="TextBox 43"/>
             <p:cNvSpPr txBox="1"/>
             <p:nvPr/>
           </p:nvSpPr>
@@ -13066,14 +13187,14 @@
         </p:sp>
         <p:sp>
           <p:nvSpPr>
-            <p:cNvPr id="40" name="TextBox 40"/>
-            <p:cNvSpPr txBox="1"/>
-            <p:nvPr/>
-          </p:nvSpPr>
-          <p:spPr>
-            <a:xfrm>
-              <a:off x="8628401" y="3955256"/>
-              <a:ext cx="2883514" cy="220028"/>
+            <p:cNvPr id="44" name="TextBox 44"/>
+            <p:cNvSpPr txBox="1"/>
+            <p:nvPr/>
+          </p:nvSpPr>
+          <p:spPr>
+            <a:xfrm>
+              <a:off x="9715053" y="3955256"/>
+              <a:ext cx="1796862" cy="220028"/>
             </a:xfrm>
             <a:prstGeom prst="rect">
               <a:avLst/>
@@ -13099,7 +13220,47 @@
                   <a:ea typeface="+mn-ea"/>
                   <a:cs typeface="+mn-cs"/>
                 </a:rPr>
-                <a:t>Windows 11 · conda base python 3.11.9</a:t>
+                <a:t>Windows 11 · conda base</a:t>
+              </a:r>
+            </a:p>
+          </p:txBody>
+        </p:sp>
+        <p:sp>
+          <p:nvSpPr>
+            <p:cNvPr id="45" name="TextBox 45"/>
+            <p:cNvSpPr txBox="1"/>
+            <p:nvPr/>
+          </p:nvSpPr>
+          <p:spPr>
+            <a:xfrm>
+              <a:off x="9248470" y="4183856"/>
+              <a:ext cx="2263445" cy="220028"/>
+            </a:xfrm>
+            <a:prstGeom prst="rect">
+              <a:avLst/>
+            </a:prstGeom>
+            <a:noFill/>
+            <a:ln>
+              <a:noFill/>
+            </a:ln>
+          </p:spPr>
+          <p:txBody>
+            <a:bodyPr wrap="none" lIns="0" tIns="0" rIns="0" bIns="0" anchor="t" anchorCtr="0">
+              <a:spAutoFit/>
+            </a:bodyPr>
+            <a:lstStyle/>
+            <a:p>
+              <a:pPr algn="r"/>
+              <a:r>
+                <a:rPr lang="zh-CN" sz="1120" dirty="0">
+                  <a:solidFill>
+                    <a:srgbClr val="94A3B8"/>
+                  </a:solidFill>
+                  <a:latin typeface="+mn-lt"/>
+                  <a:ea typeface="+mn-ea"/>
+                  <a:cs typeface="+mn-cs"/>
+                </a:rPr>
+                <a:t>python 3.11.9 · 真 Office 开档</a:t>
               </a:r>
             </a:p>
           </p:txBody>

</xml_diff>